<commit_message>
Update INARA 2026-08-28 11:42:51
</commit_message>
<xml_diff>
--- a/reports/BRANCH_DENPASAR_PERFORMANCE_SUMMARY_20260827_INARA.pptx
+++ b/reports/BRANCH_DENPASAR_PERFORMANCE_SUMMARY_20260827_INARA.pptx
@@ -13625,7 +13625,7 @@
                 </a:solidFill>
                 <a:latin typeface="Arial"/>
               </a:rPr>
-              <a:t>208</a:t>
+              <a:t>211</a:t>
             </a:r>
           </a:p>
         </p:txBody>
@@ -13660,7 +13660,7 @@
                 </a:solidFill>
                 <a:latin typeface="Arial"/>
               </a:rPr>
-              <a:t>+4,0%</a:t>
+              <a:t>+1,9%</a:t>
             </a:r>
           </a:p>
         </p:txBody>
@@ -13695,7 +13695,7 @@
                 </a:solidFill>
                 <a:latin typeface="Arial"/>
               </a:rPr>
-              <a:t>MTD-1: 200   Δ 8</a:t>
+              <a:t>MTD-1: 207   Δ 4</a:t>
             </a:r>
           </a:p>
         </p:txBody>
@@ -13812,7 +13812,7 @@
                 </a:solidFill>
                 <a:latin typeface="Arial"/>
               </a:rPr>
-              <a:t>5.573</a:t>
+              <a:t>6.012</a:t>
             </a:r>
           </a:p>
         </p:txBody>
@@ -13847,7 +13847,7 @@
                 </a:solidFill>
                 <a:latin typeface="Arial"/>
               </a:rPr>
-              <a:t>-6,2%</a:t>
+              <a:t>-5,3%</a:t>
             </a:r>
           </a:p>
         </p:txBody>
@@ -13882,7 +13882,7 @@
                 </a:solidFill>
                 <a:latin typeface="Arial"/>
               </a:rPr>
-              <a:t>MTD-1: 5.944   Δ -371</a:t>
+              <a:t>MTD-1: 6.349   Δ -337</a:t>
             </a:r>
           </a:p>
         </p:txBody>
@@ -15018,7 +15018,7 @@
                           </a:solidFill>
                           <a:latin typeface="Arial"/>
                         </a:rPr>
-                        <a:t>47</a:t>
+                        <a:t>49</a:t>
                       </a:r>
                     </a:p>
                   </a:txBody>
@@ -15112,7 +15112,7 @@
                           </a:solidFill>
                           <a:latin typeface="Arial"/>
                         </a:rPr>
-                        <a:t>+6,4%</a:t>
+                        <a:t>+2,0%</a:t>
                       </a:r>
                     </a:p>
                   </a:txBody>
@@ -15159,7 +15159,7 @@
                           </a:solidFill>
                           <a:latin typeface="Arial"/>
                         </a:rPr>
-                        <a:t>1.995</a:t>
+                        <a:t>2.104</a:t>
                       </a:r>
                     </a:p>
                   </a:txBody>
@@ -15206,7 +15206,7 @@
                           </a:solidFill>
                           <a:latin typeface="Arial"/>
                         </a:rPr>
-                        <a:t>1.198</a:t>
+                        <a:t>1.250</a:t>
                       </a:r>
                     </a:p>
                   </a:txBody>
@@ -15253,7 +15253,7 @@
                           </a:solidFill>
                           <a:latin typeface="Arial"/>
                         </a:rPr>
-                        <a:t>-39,9%</a:t>
+                        <a:t>-40,6%</a:t>
                       </a:r>
                     </a:p>
                   </a:txBody>
@@ -15725,7 +15725,7 @@
                           </a:solidFill>
                           <a:latin typeface="Arial"/>
                         </a:rPr>
-                        <a:t>80</a:t>
+                        <a:t>81</a:t>
                       </a:r>
                     </a:p>
                   </a:txBody>
@@ -15772,7 +15772,7 @@
                           </a:solidFill>
                           <a:latin typeface="Arial"/>
                         </a:rPr>
-                        <a:t>+8,1%</a:t>
+                        <a:t>+9,5%</a:t>
                       </a:r>
                     </a:p>
                   </a:txBody>
@@ -15819,7 +15819,7 @@
                           </a:solidFill>
                           <a:latin typeface="Arial"/>
                         </a:rPr>
-                        <a:t>1.714</a:t>
+                        <a:t>1.840</a:t>
                       </a:r>
                     </a:p>
                   </a:txBody>
@@ -15866,7 +15866,7 @@
                           </a:solidFill>
                           <a:latin typeface="Arial"/>
                         </a:rPr>
-                        <a:t>1.794</a:t>
+                        <a:t>1.909</a:t>
                       </a:r>
                     </a:p>
                   </a:txBody>
@@ -15913,7 +15913,7 @@
                           </a:solidFill>
                           <a:latin typeface="Arial"/>
                         </a:rPr>
-                        <a:t>+4,7%</a:t>
+                        <a:t>+3,8%</a:t>
                       </a:r>
                     </a:p>
                   </a:txBody>
@@ -16385,7 +16385,7 @@
                           </a:solidFill>
                           <a:latin typeface="Arial"/>
                         </a:rPr>
-                        <a:t>41</a:t>
+                        <a:t>43</a:t>
                       </a:r>
                     </a:p>
                   </a:txBody>
@@ -16432,7 +16432,7 @@
                           </a:solidFill>
                           <a:latin typeface="Arial"/>
                         </a:rPr>
-                        <a:t>-12,8%</a:t>
+                        <a:t>-8,5%</a:t>
                       </a:r>
                     </a:p>
                   </a:txBody>
@@ -16479,7 +16479,7 @@
                           </a:solidFill>
                           <a:latin typeface="Arial"/>
                         </a:rPr>
-                        <a:t>1.309</a:t>
+                        <a:t>1.383</a:t>
                       </a:r>
                     </a:p>
                   </a:txBody>
@@ -16526,7 +16526,7 @@
                           </a:solidFill>
                           <a:latin typeface="Arial"/>
                         </a:rPr>
-                        <a:t>1.459</a:t>
+                        <a:t>1.682</a:t>
                       </a:r>
                     </a:p>
                   </a:txBody>
@@ -16573,7 +16573,7 @@
                           </a:solidFill>
                           <a:latin typeface="Arial"/>
                         </a:rPr>
-                        <a:t>+11,5%</a:t>
+                        <a:t>+21,6%</a:t>
                       </a:r>
                     </a:p>
                   </a:txBody>
@@ -16998,7 +16998,7 @@
                           </a:solidFill>
                           <a:latin typeface="Arial"/>
                         </a:rPr>
-                        <a:t>32</a:t>
+                        <a:t>37</a:t>
                       </a:r>
                     </a:p>
                   </a:txBody>
@@ -17088,152 +17088,152 @@
                       <a:r>
                         <a:rPr sz="1050" b="0">
                           <a:solidFill>
+                            <a:srgbClr val="687386"/>
+                          </a:solidFill>
+                          <a:latin typeface="Arial"/>
+                        </a:rPr>
+                        <a:t>0,0%</a:t>
+                      </a:r>
+                    </a:p>
+                  </a:txBody>
+                  <a:tcPr marL="27432" marR="27432" marT="0" marB="0">
+                    <a:solidFill>
+                      <a:srgbClr val="E9EDF2"/>
+                    </a:solidFill>
+                    <a:lnL w="9000" cap="flat" cmpd="sng" algn="ctr">
+                      <a:solidFill>
+                        <a:srgbClr val="D8DEE7"/>
+                      </a:solidFill>
+                      <a:prstDash val="solid"/>
+                    </a:lnL>
+                    <a:lnR w="9000" cap="flat" cmpd="sng" algn="ctr">
+                      <a:solidFill>
+                        <a:srgbClr val="D8DEE7"/>
+                      </a:solidFill>
+                      <a:prstDash val="solid"/>
+                    </a:lnR>
+                    <a:lnT w="9000" cap="flat" cmpd="sng" algn="ctr">
+                      <a:solidFill>
+                        <a:srgbClr val="D8DEE7"/>
+                      </a:solidFill>
+                      <a:prstDash val="solid"/>
+                    </a:lnT>
+                    <a:lnB w="9000" cap="flat" cmpd="sng" algn="ctr">
+                      <a:solidFill>
+                        <a:srgbClr val="D8DEE7"/>
+                      </a:solidFill>
+                      <a:prstDash val="solid"/>
+                    </a:lnB>
+                  </a:tcPr>
+                </a:tc>
+                <a:tc>
+                  <a:txBody>
+                    <a:bodyPr lIns="27432" rIns="27432" tIns="0" bIns="0" anchor="ctr"/>
+                    <a:lstStyle/>
+                    <a:p>
+                      <a:pPr algn="ctr"/>
+                      <a:r>
+                        <a:rPr sz="1050" b="0">
+                          <a:solidFill>
+                            <a:srgbClr val="20252B"/>
+                          </a:solidFill>
+                          <a:latin typeface="Arial"/>
+                        </a:rPr>
+                        <a:t>1.022</a:t>
+                      </a:r>
+                    </a:p>
+                  </a:txBody>
+                  <a:tcPr marL="27432" marR="27432" marT="0" marB="0">
+                    <a:solidFill>
+                      <a:srgbClr val="FFFFFF"/>
+                    </a:solidFill>
+                    <a:lnL w="9000" cap="flat" cmpd="sng" algn="ctr">
+                      <a:solidFill>
+                        <a:srgbClr val="D8DEE7"/>
+                      </a:solidFill>
+                      <a:prstDash val="solid"/>
+                    </a:lnL>
+                    <a:lnR w="9000" cap="flat" cmpd="sng" algn="ctr">
+                      <a:solidFill>
+                        <a:srgbClr val="D8DEE7"/>
+                      </a:solidFill>
+                      <a:prstDash val="solid"/>
+                    </a:lnR>
+                    <a:lnT w="9000" cap="flat" cmpd="sng" algn="ctr">
+                      <a:solidFill>
+                        <a:srgbClr val="D8DEE7"/>
+                      </a:solidFill>
+                      <a:prstDash val="solid"/>
+                    </a:lnT>
+                    <a:lnB w="9000" cap="flat" cmpd="sng" algn="ctr">
+                      <a:solidFill>
+                        <a:srgbClr val="D8DEE7"/>
+                      </a:solidFill>
+                      <a:prstDash val="solid"/>
+                    </a:lnB>
+                  </a:tcPr>
+                </a:tc>
+                <a:tc>
+                  <a:txBody>
+                    <a:bodyPr lIns="27432" rIns="27432" tIns="0" bIns="0" anchor="ctr"/>
+                    <a:lstStyle/>
+                    <a:p>
+                      <a:pPr algn="ctr"/>
+                      <a:r>
+                        <a:rPr sz="1050" b="1">
+                          <a:solidFill>
+                            <a:srgbClr val="20252B"/>
+                          </a:solidFill>
+                          <a:latin typeface="Arial"/>
+                        </a:rPr>
+                        <a:t>1.171</a:t>
+                      </a:r>
+                    </a:p>
+                  </a:txBody>
+                  <a:tcPr marL="27432" marR="27432" marT="0" marB="0">
+                    <a:solidFill>
+                      <a:srgbClr val="FFFFFF"/>
+                    </a:solidFill>
+                    <a:lnL w="9000" cap="flat" cmpd="sng" algn="ctr">
+                      <a:solidFill>
+                        <a:srgbClr val="D8DEE7"/>
+                      </a:solidFill>
+                      <a:prstDash val="solid"/>
+                    </a:lnL>
+                    <a:lnR w="9000" cap="flat" cmpd="sng" algn="ctr">
+                      <a:solidFill>
+                        <a:srgbClr val="D8DEE7"/>
+                      </a:solidFill>
+                      <a:prstDash val="solid"/>
+                    </a:lnR>
+                    <a:lnT w="9000" cap="flat" cmpd="sng" algn="ctr">
+                      <a:solidFill>
+                        <a:srgbClr val="D8DEE7"/>
+                      </a:solidFill>
+                      <a:prstDash val="solid"/>
+                    </a:lnT>
+                    <a:lnB w="9000" cap="flat" cmpd="sng" algn="ctr">
+                      <a:solidFill>
+                        <a:srgbClr val="D8DEE7"/>
+                      </a:solidFill>
+                      <a:prstDash val="solid"/>
+                    </a:lnB>
+                  </a:tcPr>
+                </a:tc>
+                <a:tc>
+                  <a:txBody>
+                    <a:bodyPr lIns="27432" rIns="27432" tIns="0" bIns="0" anchor="ctr"/>
+                    <a:lstStyle/>
+                    <a:p>
+                      <a:pPr algn="ctr"/>
+                      <a:r>
+                        <a:rPr sz="1050" b="0">
+                          <a:solidFill>
                             <a:srgbClr val="137D3F"/>
                           </a:solidFill>
                           <a:latin typeface="Arial"/>
                         </a:rPr>
-                        <a:t>+15,6%</a:t>
-                      </a:r>
-                    </a:p>
-                  </a:txBody>
-                  <a:tcPr marL="27432" marR="27432" marT="0" marB="0">
-                    <a:solidFill>
-                      <a:srgbClr val="E5F4EA"/>
-                    </a:solidFill>
-                    <a:lnL w="9000" cap="flat" cmpd="sng" algn="ctr">
-                      <a:solidFill>
-                        <a:srgbClr val="D8DEE7"/>
-                      </a:solidFill>
-                      <a:prstDash val="solid"/>
-                    </a:lnL>
-                    <a:lnR w="9000" cap="flat" cmpd="sng" algn="ctr">
-                      <a:solidFill>
-                        <a:srgbClr val="D8DEE7"/>
-                      </a:solidFill>
-                      <a:prstDash val="solid"/>
-                    </a:lnR>
-                    <a:lnT w="9000" cap="flat" cmpd="sng" algn="ctr">
-                      <a:solidFill>
-                        <a:srgbClr val="D8DEE7"/>
-                      </a:solidFill>
-                      <a:prstDash val="solid"/>
-                    </a:lnT>
-                    <a:lnB w="9000" cap="flat" cmpd="sng" algn="ctr">
-                      <a:solidFill>
-                        <a:srgbClr val="D8DEE7"/>
-                      </a:solidFill>
-                      <a:prstDash val="solid"/>
-                    </a:lnB>
-                  </a:tcPr>
-                </a:tc>
-                <a:tc>
-                  <a:txBody>
-                    <a:bodyPr lIns="27432" rIns="27432" tIns="0" bIns="0" anchor="ctr"/>
-                    <a:lstStyle/>
-                    <a:p>
-                      <a:pPr algn="ctr"/>
-                      <a:r>
-                        <a:rPr sz="1050" b="0">
-                          <a:solidFill>
-                            <a:srgbClr val="20252B"/>
-                          </a:solidFill>
-                          <a:latin typeface="Arial"/>
-                        </a:rPr>
-                        <a:t>926</a:t>
-                      </a:r>
-                    </a:p>
-                  </a:txBody>
-                  <a:tcPr marL="27432" marR="27432" marT="0" marB="0">
-                    <a:solidFill>
-                      <a:srgbClr val="FFFFFF"/>
-                    </a:solidFill>
-                    <a:lnL w="9000" cap="flat" cmpd="sng" algn="ctr">
-                      <a:solidFill>
-                        <a:srgbClr val="D8DEE7"/>
-                      </a:solidFill>
-                      <a:prstDash val="solid"/>
-                    </a:lnL>
-                    <a:lnR w="9000" cap="flat" cmpd="sng" algn="ctr">
-                      <a:solidFill>
-                        <a:srgbClr val="D8DEE7"/>
-                      </a:solidFill>
-                      <a:prstDash val="solid"/>
-                    </a:lnR>
-                    <a:lnT w="9000" cap="flat" cmpd="sng" algn="ctr">
-                      <a:solidFill>
-                        <a:srgbClr val="D8DEE7"/>
-                      </a:solidFill>
-                      <a:prstDash val="solid"/>
-                    </a:lnT>
-                    <a:lnB w="9000" cap="flat" cmpd="sng" algn="ctr">
-                      <a:solidFill>
-                        <a:srgbClr val="D8DEE7"/>
-                      </a:solidFill>
-                      <a:prstDash val="solid"/>
-                    </a:lnB>
-                  </a:tcPr>
-                </a:tc>
-                <a:tc>
-                  <a:txBody>
-                    <a:bodyPr lIns="27432" rIns="27432" tIns="0" bIns="0" anchor="ctr"/>
-                    <a:lstStyle/>
-                    <a:p>
-                      <a:pPr algn="ctr"/>
-                      <a:r>
-                        <a:rPr sz="1050" b="1">
-                          <a:solidFill>
-                            <a:srgbClr val="20252B"/>
-                          </a:solidFill>
-                          <a:latin typeface="Arial"/>
-                        </a:rPr>
-                        <a:t>1.122</a:t>
-                      </a:r>
-                    </a:p>
-                  </a:txBody>
-                  <a:tcPr marL="27432" marR="27432" marT="0" marB="0">
-                    <a:solidFill>
-                      <a:srgbClr val="FFFFFF"/>
-                    </a:solidFill>
-                    <a:lnL w="9000" cap="flat" cmpd="sng" algn="ctr">
-                      <a:solidFill>
-                        <a:srgbClr val="D8DEE7"/>
-                      </a:solidFill>
-                      <a:prstDash val="solid"/>
-                    </a:lnL>
-                    <a:lnR w="9000" cap="flat" cmpd="sng" algn="ctr">
-                      <a:solidFill>
-                        <a:srgbClr val="D8DEE7"/>
-                      </a:solidFill>
-                      <a:prstDash val="solid"/>
-                    </a:lnR>
-                    <a:lnT w="9000" cap="flat" cmpd="sng" algn="ctr">
-                      <a:solidFill>
-                        <a:srgbClr val="D8DEE7"/>
-                      </a:solidFill>
-                      <a:prstDash val="solid"/>
-                    </a:lnT>
-                    <a:lnB w="9000" cap="flat" cmpd="sng" algn="ctr">
-                      <a:solidFill>
-                        <a:srgbClr val="D8DEE7"/>
-                      </a:solidFill>
-                      <a:prstDash val="solid"/>
-                    </a:lnB>
-                  </a:tcPr>
-                </a:tc>
-                <a:tc>
-                  <a:txBody>
-                    <a:bodyPr lIns="27432" rIns="27432" tIns="0" bIns="0" anchor="ctr"/>
-                    <a:lstStyle/>
-                    <a:p>
-                      <a:pPr algn="ctr"/>
-                      <a:r>
-                        <a:rPr sz="1050" b="0">
-                          <a:solidFill>
-                            <a:srgbClr val="137D3F"/>
-                          </a:solidFill>
-                          <a:latin typeface="Arial"/>
-                        </a:rPr>
-                        <a:t>+21,2%</a:t>
+                        <a:t>+14,6%</a:t>
                       </a:r>
                     </a:p>
                   </a:txBody>
@@ -26835,7 +26835,7 @@
                 </a:solidFill>
                 <a:latin typeface="Arial"/>
               </a:rPr>
-              <a:t>ODP dikunjungi  541 (16,4%)</a:t>
+              <a:t>ODP dikunjungi  547 (16,6%)</a:t>
             </a:r>
           </a:p>
         </p:txBody>
@@ -26905,7 +26905,7 @@
                 </a:solidFill>
                 <a:latin typeface="Arial"/>
               </a:rPr>
-              <a:t>1.655</a:t>
+              <a:t>1.809</a:t>
             </a:r>
           </a:p>
         </p:txBody>
@@ -27057,7 +27057,7 @@
                 </a:solidFill>
                 <a:latin typeface="Arial"/>
               </a:rPr>
-              <a:t>ODP dikunjungi  196 (59,9%)</a:t>
+              <a:t>ODP dikunjungi  201 (61,5%)</a:t>
             </a:r>
           </a:p>
         </p:txBody>
@@ -27127,7 +27127,7 @@
                 </a:solidFill>
                 <a:latin typeface="Arial"/>
               </a:rPr>
-              <a:t>479</a:t>
+              <a:t>651</a:t>
             </a:r>
           </a:p>
         </p:txBody>

</xml_diff>